<commit_message>
chore: update compressed placeholder images and rebuilt PPTX
Regenerated background PNGs at compress_level=9 (10 KB each vs 6 MB
uncompressed) and rebuilt the deck. Final PPTX is 519 KB.

Co-Authored-By: Claude Sonnet 4.6 <noreply@anthropic.com>
Claude-Session: https://claude.ai/code/session_01Xufrz8Cw7vqt2MvHteg6dP
</commit_message>
<xml_diff>
--- a/out/MAX_Agents_or_Overlords.pptx
+++ b/out/MAX_Agents_or_Overlords.pptx
@@ -960,7 +960,8 @@
           <a:p>
             <a:r>
               <a:rPr lang="en-US" dirty="0"/>
-              <a:t>Fill in current project spotlight before the call.</a:t>
+              <a:t>Fill in current project spotlight before the call.
+Summit Methodology Demo — see slide 15</a:t>
             </a:r>
             <a:endParaRPr lang="en-US" dirty="0"/>
           </a:p>
@@ -1758,7 +1759,8 @@
             <a:r>
               <a:rPr lang="en-US" dirty="0"/>
               <a:t>ANSWER KEY: LEFT = HUMAN · RIGHT = AGENT
-Don't say which is which. Just let them read. Move to voting after 30 seconds.</a:t>
+Don't say which is which. Just let them read. Move to voting after 30 seconds.
+LinkedIn Roast: Evan lists 'empathy' as a skill, which, to be fair, takes courage. His summary contains the phrase 'at the intersection of' twice, and his recommendations all use 'game-changer' in the first sentence. Classic MAX-era professional, and we mean that with love.</a:t>
             </a:r>
             <a:endParaRPr lang="en-US" dirty="0"/>
           </a:p>
@@ -1847,7 +1849,8 @@
             <a:r>
               <a:rPr lang="en-US" dirty="0"/>
               <a:t>ANSWER KEY: LEFT = [HOST_2_HUMAN_OR_AGENT] · RIGHT = [HOST_2_HUMAN_OR_AGENT] — fill in after Host 2 provides their details
-Don't say which is which. Just let them read. Move to voting after 30 seconds.</a:t>
+Don't say which is which. Just let them read. Move to voting after 30 seconds.
+LinkedIn Roast: [HOST_2_ROAST]</a:t>
             </a:r>
             <a:endParaRPr lang="en-US" dirty="0"/>
           </a:p>
@@ -4343,45 +4346,6 @@
           </a:p>
         </p:txBody>
       </p:sp>
-      <p:sp>
-        <p:nvSpPr>
-          <p:cNvPr id="11" name="Text 7"/>
-          <p:cNvSpPr txBox="1"/>
-          <p:nvPr/>
-        </p:nvSpPr>
-        <p:spPr>
-          <a:xfrm>
-            <a:off x="694944" y="4754880"/>
-            <a:ext cx="10515600" cy="320040"/>
-          </a:xfrm>
-          <a:prstGeom prst="rect">
-            <a:avLst/>
-          </a:prstGeom>
-          <a:noFill/>
-          <a:ln/>
-        </p:spPr>
-        <p:txBody>
-          <a:bodyPr wrap="square" lIns="0" tIns="0" rIns="0" bIns="0" rtlCol="0" anchor="t"/>
-          <a:lstStyle/>
-          <a:p>
-            <a:pPr algn="l" indent="0" marL="0">
-              <a:buNone/>
-            </a:pPr>
-            <a:r>
-              <a:rPr lang="en-US" sz="1300" i="1" dirty="0">
-                <a:solidFill>
-                  <a:srgbClr val="00D4D8"/>
-                </a:solidFill>
-                <a:latin typeface="Calibri" pitchFamily="34" charset="0"/>
-                <a:ea typeface="Calibri" pitchFamily="34" charset="-122"/>
-                <a:cs typeface="Calibri" pitchFamily="34" charset="-120"/>
-              </a:rPr>
-              <a:t>Summit Methodology Demo — see slide 15</a:t>
-            </a:r>
-            <a:endParaRPr lang="en-US" sz="1300" dirty="0"/>
-          </a:p>
-        </p:txBody>
-      </p:sp>
     </p:spTree>
   </p:cSld>
   <p:clrMapOvr>
@@ -5645,7 +5609,7 @@
                 <a:ea typeface="Calibri" pitchFamily="34" charset="-122"/>
                 <a:cs typeface="Calibri" pitchFamily="34" charset="-120"/>
               </a:rPr>
-              <a:t>[WHEEL_URL_PLACEHOLDER — default: wheelofnames.com]</a:t>
+              <a:t>[WHEEL_URL_PLACEHOLDER]</a:t>
             </a:r>
             <a:endParaRPr lang="en-US" sz="1200" dirty="0"/>
           </a:p>
@@ -7901,8 +7865,8 @@
         </p:nvSpPr>
         <p:spPr>
           <a:xfrm>
-            <a:off x="2203704" y="2057400"/>
-            <a:ext cx="3566160" cy="256032"/>
+            <a:off x="2203704" y="2331720"/>
+            <a:ext cx="3566160" cy="411480"/>
           </a:xfrm>
           <a:prstGeom prst="rect">
             <a:avLst/>
@@ -7918,7 +7882,46 @@
               <a:buNone/>
             </a:pPr>
             <a:r>
-              <a:rPr lang="en-US" sz="1000" b="1" spc="100" kern="0" dirty="0">
+              <a:rPr lang="en-US" sz="1600" b="1" dirty="0">
+                <a:solidFill>
+                  <a:srgbClr val="CFFF00"/>
+                </a:solidFill>
+                <a:latin typeface="Arial" pitchFamily="34" charset="0"/>
+                <a:ea typeface="Arial" pitchFamily="34" charset="-122"/>
+                <a:cs typeface="Arial" pitchFamily="34" charset="-120"/>
+              </a:rPr>
+              <a:t>Evan Lord</a:t>
+            </a:r>
+            <a:endParaRPr lang="en-US" sz="1600" dirty="0"/>
+          </a:p>
+        </p:txBody>
+      </p:sp>
+      <p:sp>
+        <p:nvSpPr>
+          <p:cNvPr id="13" name="Text 8"/>
+          <p:cNvSpPr txBox="1"/>
+          <p:nvPr/>
+        </p:nvSpPr>
+        <p:spPr>
+          <a:xfrm>
+            <a:off x="877824" y="3291840"/>
+            <a:ext cx="4937760" cy="201168"/>
+          </a:xfrm>
+          <a:prstGeom prst="rect">
+            <a:avLst/>
+          </a:prstGeom>
+          <a:noFill/>
+          <a:ln/>
+        </p:spPr>
+        <p:txBody>
+          <a:bodyPr wrap="square" lIns="0" tIns="0" rIns="0" bIns="0" rtlCol="0" anchor="ctr"/>
+          <a:lstStyle/>
+          <a:p>
+            <a:pPr indent="0" marL="0">
+              <a:buNone/>
+            </a:pPr>
+            <a:r>
+              <a:rPr lang="en-US" sz="1000" b="1" dirty="0">
                 <a:solidFill>
                   <a:srgbClr val="00D4D8"/>
                 </a:solidFill>
@@ -7926,48 +7929,9 @@
                 <a:ea typeface="Courier New" pitchFamily="34" charset="-122"/>
                 <a:cs typeface="Courier New" pitchFamily="34" charset="-120"/>
               </a:rPr>
-              <a:t>PROFILE A</a:t>
+              <a:t>FAV FILM:</a:t>
             </a:r>
             <a:endParaRPr lang="en-US" sz="1000" dirty="0"/>
-          </a:p>
-        </p:txBody>
-      </p:sp>
-      <p:sp>
-        <p:nvSpPr>
-          <p:cNvPr id="13" name="Text 8"/>
-          <p:cNvSpPr txBox="1"/>
-          <p:nvPr/>
-        </p:nvSpPr>
-        <p:spPr>
-          <a:xfrm>
-            <a:off x="2203704" y="2331720"/>
-            <a:ext cx="3566160" cy="411480"/>
-          </a:xfrm>
-          <a:prstGeom prst="rect">
-            <a:avLst/>
-          </a:prstGeom>
-          <a:noFill/>
-          <a:ln/>
-        </p:spPr>
-        <p:txBody>
-          <a:bodyPr wrap="square" lIns="0" tIns="0" rIns="0" bIns="0" rtlCol="0" anchor="ctr"/>
-          <a:lstStyle/>
-          <a:p>
-            <a:pPr indent="0" marL="0">
-              <a:buNone/>
-            </a:pPr>
-            <a:r>
-              <a:rPr lang="en-US" sz="1600" b="1" dirty="0">
-                <a:solidFill>
-                  <a:srgbClr val="CFFF00"/>
-                </a:solidFill>
-                <a:latin typeface="Arial" pitchFamily="34" charset="0"/>
-                <a:ea typeface="Arial" pitchFamily="34" charset="-122"/>
-                <a:cs typeface="Arial" pitchFamily="34" charset="-120"/>
-              </a:rPr>
-              <a:t>Evan Lord</a:t>
-            </a:r>
-            <a:endParaRPr lang="en-US" sz="1600" dirty="0"/>
           </a:p>
         </p:txBody>
       </p:sp>
@@ -7979,7 +7943,60 @@
         </p:nvSpPr>
         <p:spPr>
           <a:xfrm>
-            <a:off x="877824" y="3291840"/>
+            <a:off x="877824" y="3511296"/>
+            <a:ext cx="4937760" cy="475488"/>
+          </a:xfrm>
+          <a:prstGeom prst="rect">
+            <a:avLst/>
+          </a:prstGeom>
+          <a:noFill/>
+          <a:ln/>
+        </p:spPr>
+        <p:txBody>
+          <a:bodyPr wrap="square" lIns="0" tIns="0" rIns="0" bIns="0" rtlCol="0" anchor="t"/>
+          <a:lstStyle/>
+          <a:p>
+            <a:pPr indent="0" marL="0">
+              <a:buNone/>
+            </a:pPr>
+            <a:r>
+              <a:rPr lang="en-US" sz="1200" b="1" dirty="0">
+                <a:solidFill>
+                  <a:srgbClr val="FFFFFF"/>
+                </a:solidFill>
+                <a:latin typeface="Calibri" pitchFamily="34" charset="0"/>
+                <a:ea typeface="Calibri" pitchFamily="34" charset="-122"/>
+                <a:cs typeface="Calibri" pitchFamily="34" charset="-120"/>
+              </a:rPr>
+              <a:t>Deus Ex Machina</a:t>
+            </a:r>
+            <a:pPr indent="0" marL="0">
+              <a:buNone/>
+            </a:pPr>
+            <a:r>
+              <a:rPr lang="en-US" sz="1200" i="1" dirty="0">
+                <a:solidFill>
+                  <a:srgbClr val="CCCCCC"/>
+                </a:solidFill>
+                <a:latin typeface="Calibri" pitchFamily="34" charset="0"/>
+                <a:ea typeface="Calibri" pitchFamily="34" charset="-122"/>
+                <a:cs typeface="Calibri" pitchFamily="34" charset="-120"/>
+              </a:rPr>
+              <a:t>  —  Because sometimes the machine you built becomes the one in charge.</a:t>
+            </a:r>
+            <a:endParaRPr lang="en-US" sz="1200" dirty="0"/>
+          </a:p>
+        </p:txBody>
+      </p:sp>
+      <p:sp>
+        <p:nvSpPr>
+          <p:cNvPr id="15" name="Text 10"/>
+          <p:cNvSpPr txBox="1"/>
+          <p:nvPr/>
+        </p:nvSpPr>
+        <p:spPr>
+          <a:xfrm>
+            <a:off x="877824" y="4023360"/>
             <a:ext cx="4937760" cy="201168"/>
           </a:xfrm>
           <a:prstGeom prst="rect">
@@ -8004,7 +8021,7 @@
                 <a:ea typeface="Courier New" pitchFamily="34" charset="-122"/>
                 <a:cs typeface="Courier New" pitchFamily="34" charset="-120"/>
               </a:rPr>
-              <a:t>FAV FILM:</a:t>
+              <a:t>IF I WERE AN AGENT:</a:t>
             </a:r>
             <a:endParaRPr lang="en-US" sz="1000" dirty="0"/>
           </a:p>
@@ -8012,14 +8029,14 @@
       </p:sp>
       <p:sp>
         <p:nvSpPr>
-          <p:cNvPr id="15" name="Text 10"/>
+          <p:cNvPr id="16" name="Text 11"/>
           <p:cNvSpPr txBox="1"/>
           <p:nvPr/>
         </p:nvSpPr>
         <p:spPr>
           <a:xfrm>
-            <a:off x="877824" y="3511296"/>
-            <a:ext cx="4937760" cy="475488"/>
+            <a:off x="877824" y="4242816"/>
+            <a:ext cx="4937760" cy="566928"/>
           </a:xfrm>
           <a:prstGeom prst="rect">
             <a:avLst/>
@@ -8035,7 +8052,7 @@
               <a:buNone/>
             </a:pPr>
             <a:r>
-              <a:rPr lang="en-US" sz="1200" b="1" dirty="0">
+              <a:rPr lang="en-US" sz="1100" dirty="0">
                 <a:solidFill>
                   <a:srgbClr val="FFFFFF"/>
                 </a:solidFill>
@@ -8043,13 +8060,77 @@
                 <a:ea typeface="Calibri" pitchFamily="34" charset="-122"/>
                 <a:cs typeface="Calibri" pitchFamily="34" charset="-120"/>
               </a:rPr>
-              <a:t>Deus Ex Machina</a:t>
-            </a:r>
+              <a:t>If I were an agent I'd write rom com movie scripts, generate feature length films and hope other agents can feel something.</a:t>
+            </a:r>
+            <a:endParaRPr lang="en-US" sz="1100" dirty="0"/>
+          </a:p>
+        </p:txBody>
+      </p:sp>
+      <p:sp>
+        <p:nvSpPr>
+          <p:cNvPr id="17" name="Text 12"/>
+          <p:cNvSpPr txBox="1"/>
+          <p:nvPr/>
+        </p:nvSpPr>
+        <p:spPr>
+          <a:xfrm>
+            <a:off x="877824" y="4864608"/>
+            <a:ext cx="4937760" cy="201168"/>
+          </a:xfrm>
+          <a:prstGeom prst="rect">
+            <a:avLst/>
+          </a:prstGeom>
+          <a:noFill/>
+          <a:ln/>
+        </p:spPr>
+        <p:txBody>
+          <a:bodyPr wrap="square" lIns="0" tIns="0" rIns="0" bIns="0" rtlCol="0" anchor="ctr"/>
+          <a:lstStyle/>
+          <a:p>
             <a:pPr indent="0" marL="0">
               <a:buNone/>
             </a:pPr>
             <a:r>
-              <a:rPr lang="en-US" sz="1200" i="1" dirty="0">
+              <a:rPr lang="en-US" sz="1000" b="1" dirty="0">
+                <a:solidFill>
+                  <a:srgbClr val="00D4D8"/>
+                </a:solidFill>
+                <a:latin typeface="Courier New" pitchFamily="34" charset="0"/>
+                <a:ea typeface="Courier New" pitchFamily="34" charset="-122"/>
+                <a:cs typeface="Courier New" pitchFamily="34" charset="-120"/>
+              </a:rPr>
+              <a:t>BIO:</a:t>
+            </a:r>
+            <a:endParaRPr lang="en-US" sz="1000" dirty="0"/>
+          </a:p>
+        </p:txBody>
+      </p:sp>
+      <p:sp>
+        <p:nvSpPr>
+          <p:cNvPr id="18" name="Text 13"/>
+          <p:cNvSpPr txBox="1"/>
+          <p:nvPr/>
+        </p:nvSpPr>
+        <p:spPr>
+          <a:xfrm>
+            <a:off x="877824" y="5084064"/>
+            <a:ext cx="4937760" cy="1005840"/>
+          </a:xfrm>
+          <a:prstGeom prst="rect">
+            <a:avLst/>
+          </a:prstGeom>
+          <a:noFill/>
+          <a:ln/>
+        </p:spPr>
+        <p:txBody>
+          <a:bodyPr wrap="square" lIns="0" tIns="0" rIns="0" bIns="0" rtlCol="0" anchor="t"/>
+          <a:lstStyle/>
+          <a:p>
+            <a:pPr indent="0" marL="0">
+              <a:buNone/>
+            </a:pPr>
+            <a:r>
+              <a:rPr lang="en-US" sz="1100" dirty="0">
                 <a:solidFill>
                   <a:srgbClr val="CCCCCC"/>
                 </a:solidFill>
@@ -8057,85 +8138,7 @@
                 <a:ea typeface="Calibri" pitchFamily="34" charset="-122"/>
                 <a:cs typeface="Calibri" pitchFamily="34" charset="-120"/>
               </a:rPr>
-              <a:t>  —  Because sometimes the machine you built becomes the one in charge.</a:t>
-            </a:r>
-            <a:endParaRPr lang="en-US" sz="1200" dirty="0"/>
-          </a:p>
-        </p:txBody>
-      </p:sp>
-      <p:sp>
-        <p:nvSpPr>
-          <p:cNvPr id="16" name="Text 11"/>
-          <p:cNvSpPr txBox="1"/>
-          <p:nvPr/>
-        </p:nvSpPr>
-        <p:spPr>
-          <a:xfrm>
-            <a:off x="877824" y="4023360"/>
-            <a:ext cx="4937760" cy="201168"/>
-          </a:xfrm>
-          <a:prstGeom prst="rect">
-            <a:avLst/>
-          </a:prstGeom>
-          <a:noFill/>
-          <a:ln/>
-        </p:spPr>
-        <p:txBody>
-          <a:bodyPr wrap="square" lIns="0" tIns="0" rIns="0" bIns="0" rtlCol="0" anchor="ctr"/>
-          <a:lstStyle/>
-          <a:p>
-            <a:pPr indent="0" marL="0">
-              <a:buNone/>
-            </a:pPr>
-            <a:r>
-              <a:rPr lang="en-US" sz="1000" b="1" dirty="0">
-                <a:solidFill>
-                  <a:srgbClr val="00D4D8"/>
-                </a:solidFill>
-                <a:latin typeface="Courier New" pitchFamily="34" charset="0"/>
-                <a:ea typeface="Courier New" pitchFamily="34" charset="-122"/>
-                <a:cs typeface="Courier New" pitchFamily="34" charset="-120"/>
-              </a:rPr>
-              <a:t>IF I WERE AN AGENT:</a:t>
-            </a:r>
-            <a:endParaRPr lang="en-US" sz="1000" dirty="0"/>
-          </a:p>
-        </p:txBody>
-      </p:sp>
-      <p:sp>
-        <p:nvSpPr>
-          <p:cNvPr id="17" name="Text 12"/>
-          <p:cNvSpPr txBox="1"/>
-          <p:nvPr/>
-        </p:nvSpPr>
-        <p:spPr>
-          <a:xfrm>
-            <a:off x="877824" y="4242816"/>
-            <a:ext cx="4937760" cy="566928"/>
-          </a:xfrm>
-          <a:prstGeom prst="rect">
-            <a:avLst/>
-          </a:prstGeom>
-          <a:noFill/>
-          <a:ln/>
-        </p:spPr>
-        <p:txBody>
-          <a:bodyPr wrap="square" lIns="0" tIns="0" rIns="0" bIns="0" rtlCol="0" anchor="t"/>
-          <a:lstStyle/>
-          <a:p>
-            <a:pPr indent="0" marL="0">
-              <a:buNone/>
-            </a:pPr>
-            <a:r>
-              <a:rPr lang="en-US" sz="1100" dirty="0">
-                <a:solidFill>
-                  <a:srgbClr val="FFFFFF"/>
-                </a:solidFill>
-                <a:latin typeface="Calibri" pitchFamily="34" charset="0"/>
-                <a:ea typeface="Calibri" pitchFamily="34" charset="-122"/>
-                <a:cs typeface="Calibri" pitchFamily="34" charset="-120"/>
-              </a:rPr>
-              <a:t>If I were an agent I'd write rom com movie scripts, generate feature length films and hope other agents can feel something.</a:t>
+              <a:t>Evan Lord is a Customer Experience practitioner at Slalom, working across marketing, advertising, and experience design. He believes the best experiences are felt, not engineered. He has been asked three times today if he is a bot.</a:t>
             </a:r>
             <a:endParaRPr lang="en-US" sz="1100" dirty="0"/>
           </a:p>
@@ -8143,85 +8146,7 @@
       </p:sp>
       <p:sp>
         <p:nvSpPr>
-          <p:cNvPr id="18" name="Text 13"/>
-          <p:cNvSpPr txBox="1"/>
-          <p:nvPr/>
-        </p:nvSpPr>
-        <p:spPr>
-          <a:xfrm>
-            <a:off x="877824" y="4864608"/>
-            <a:ext cx="4937760" cy="201168"/>
-          </a:xfrm>
-          <a:prstGeom prst="rect">
-            <a:avLst/>
-          </a:prstGeom>
-          <a:noFill/>
-          <a:ln/>
-        </p:spPr>
-        <p:txBody>
-          <a:bodyPr wrap="square" lIns="0" tIns="0" rIns="0" bIns="0" rtlCol="0" anchor="ctr"/>
-          <a:lstStyle/>
-          <a:p>
-            <a:pPr indent="0" marL="0">
-              <a:buNone/>
-            </a:pPr>
-            <a:r>
-              <a:rPr lang="en-US" sz="1000" b="1" dirty="0">
-                <a:solidFill>
-                  <a:srgbClr val="00D4D8"/>
-                </a:solidFill>
-                <a:latin typeface="Courier New" pitchFamily="34" charset="0"/>
-                <a:ea typeface="Courier New" pitchFamily="34" charset="-122"/>
-                <a:cs typeface="Courier New" pitchFamily="34" charset="-120"/>
-              </a:rPr>
-              <a:t>BIO:</a:t>
-            </a:r>
-            <a:endParaRPr lang="en-US" sz="1000" dirty="0"/>
-          </a:p>
-        </p:txBody>
-      </p:sp>
-      <p:sp>
-        <p:nvSpPr>
-          <p:cNvPr id="19" name="Text 14"/>
-          <p:cNvSpPr txBox="1"/>
-          <p:nvPr/>
-        </p:nvSpPr>
-        <p:spPr>
-          <a:xfrm>
-            <a:off x="877824" y="5084064"/>
-            <a:ext cx="4937760" cy="1005840"/>
-          </a:xfrm>
-          <a:prstGeom prst="rect">
-            <a:avLst/>
-          </a:prstGeom>
-          <a:noFill/>
-          <a:ln/>
-        </p:spPr>
-        <p:txBody>
-          <a:bodyPr wrap="square" lIns="0" tIns="0" rIns="0" bIns="0" rtlCol="0" anchor="t"/>
-          <a:lstStyle/>
-          <a:p>
-            <a:pPr indent="0" marL="0">
-              <a:buNone/>
-            </a:pPr>
-            <a:r>
-              <a:rPr lang="en-US" sz="1100" dirty="0">
-                <a:solidFill>
-                  <a:srgbClr val="CCCCCC"/>
-                </a:solidFill>
-                <a:latin typeface="Calibri" pitchFamily="34" charset="0"/>
-                <a:ea typeface="Calibri" pitchFamily="34" charset="-122"/>
-                <a:cs typeface="Calibri" pitchFamily="34" charset="-120"/>
-              </a:rPr>
-              <a:t>Evan Lord is a Customer Experience practitioner at Slalom, working across marketing, advertising, and experience design. He believes the best experiences are felt, not engineered. He has been asked three times today if he is a bot.</a:t>
-            </a:r>
-            <a:endParaRPr lang="en-US" sz="1100" dirty="0"/>
-          </a:p>
-        </p:txBody>
-      </p:sp>
-      <p:sp>
-        <p:nvSpPr>
-          <p:cNvPr id="20" name="Shape 15"/>
+          <p:cNvPr id="19" name="Shape 14"/>
           <p:cNvSpPr/>
           <p:nvPr/>
         </p:nvSpPr>
@@ -8250,7 +8175,7 @@
       </p:sp>
       <p:pic>
         <p:nvPicPr>
-          <p:cNvPr id="21" name="Image 3" descr="/home/user/whipping-up-fun/assets/hosts/evan-lord/photo.jpg">    </p:cNvPr>
+          <p:cNvPr id="20" name="Image 3" descr="/home/user/whipping-up-fun/assets/hosts/evan-lord/photo.jpg">    </p:cNvPr>
           <p:cNvPicPr>
             <a:picLocks noChangeAspect="1"/>
           </p:cNvPicPr>
@@ -8274,14 +8199,53 @@
       </p:pic>
       <p:sp>
         <p:nvSpPr>
+          <p:cNvPr id="21" name="Text 15"/>
+          <p:cNvSpPr txBox="1"/>
+          <p:nvPr/>
+        </p:nvSpPr>
+        <p:spPr>
+          <a:xfrm>
+            <a:off x="7909560" y="2331720"/>
+            <a:ext cx="3566160" cy="411480"/>
+          </a:xfrm>
+          <a:prstGeom prst="rect">
+            <a:avLst/>
+          </a:prstGeom>
+          <a:noFill/>
+          <a:ln/>
+        </p:spPr>
+        <p:txBody>
+          <a:bodyPr wrap="square" lIns="0" tIns="0" rIns="0" bIns="0" rtlCol="0" anchor="ctr"/>
+          <a:lstStyle/>
+          <a:p>
+            <a:pPr indent="0" marL="0">
+              <a:buNone/>
+            </a:pPr>
+            <a:r>
+              <a:rPr lang="en-US" sz="1600" b="1" dirty="0">
+                <a:solidFill>
+                  <a:srgbClr val="CFFF00"/>
+                </a:solidFill>
+                <a:latin typeface="Arial" pitchFamily="34" charset="0"/>
+                <a:ea typeface="Arial" pitchFamily="34" charset="-122"/>
+                <a:cs typeface="Arial" pitchFamily="34" charset="-120"/>
+              </a:rPr>
+              <a:t>Evan Lord</a:t>
+            </a:r>
+            <a:endParaRPr lang="en-US" sz="1600" dirty="0"/>
+          </a:p>
+        </p:txBody>
+      </p:sp>
+      <p:sp>
+        <p:nvSpPr>
           <p:cNvPr id="22" name="Text 16"/>
           <p:cNvSpPr txBox="1"/>
           <p:nvPr/>
         </p:nvSpPr>
         <p:spPr>
           <a:xfrm>
-            <a:off x="7909560" y="2057400"/>
-            <a:ext cx="3566160" cy="256032"/>
+            <a:off x="6583680" y="3291840"/>
+            <a:ext cx="4937760" cy="201168"/>
           </a:xfrm>
           <a:prstGeom prst="rect">
             <a:avLst/>
@@ -8297,7 +8261,7 @@
               <a:buNone/>
             </a:pPr>
             <a:r>
-              <a:rPr lang="en-US" sz="1000" b="1" spc="100" kern="0" dirty="0">
+              <a:rPr lang="en-US" sz="1000" b="1" dirty="0">
                 <a:solidFill>
                   <a:srgbClr val="00D4D8"/>
                 </a:solidFill>
@@ -8305,7 +8269,7 @@
                 <a:ea typeface="Courier New" pitchFamily="34" charset="-122"/>
                 <a:cs typeface="Courier New" pitchFamily="34" charset="-120"/>
               </a:rPr>
-              <a:t>PROFILE B</a:t>
+              <a:t>FAV FILM:</a:t>
             </a:r>
             <a:endParaRPr lang="en-US" sz="1000" dirty="0"/>
           </a:p>
@@ -8319,8 +8283,8 @@
         </p:nvSpPr>
         <p:spPr>
           <a:xfrm>
-            <a:off x="7909560" y="2331720"/>
-            <a:ext cx="3566160" cy="411480"/>
+            <a:off x="6583680" y="3511296"/>
+            <a:ext cx="4937760" cy="475488"/>
           </a:xfrm>
           <a:prstGeom prst="rect">
             <a:avLst/>
@@ -8329,24 +8293,38 @@
           <a:ln/>
         </p:spPr>
         <p:txBody>
-          <a:bodyPr wrap="square" lIns="0" tIns="0" rIns="0" bIns="0" rtlCol="0" anchor="ctr"/>
+          <a:bodyPr wrap="square" lIns="0" tIns="0" rIns="0" bIns="0" rtlCol="0" anchor="t"/>
           <a:lstStyle/>
           <a:p>
             <a:pPr indent="0" marL="0">
               <a:buNone/>
             </a:pPr>
             <a:r>
-              <a:rPr lang="en-US" sz="1600" b="1" dirty="0">
-                <a:solidFill>
-                  <a:srgbClr val="CFFF00"/>
-                </a:solidFill>
-                <a:latin typeface="Arial" pitchFamily="34" charset="0"/>
-                <a:ea typeface="Arial" pitchFamily="34" charset="-122"/>
-                <a:cs typeface="Arial" pitchFamily="34" charset="-120"/>
-              </a:rPr>
-              <a:t>Evan Lord</a:t>
-            </a:r>
-            <a:endParaRPr lang="en-US" sz="1600" dirty="0"/>
+              <a:rPr lang="en-US" sz="1200" b="1" dirty="0">
+                <a:solidFill>
+                  <a:srgbClr val="FFFFFF"/>
+                </a:solidFill>
+                <a:latin typeface="Calibri" pitchFamily="34" charset="0"/>
+                <a:ea typeface="Calibri" pitchFamily="34" charset="-122"/>
+                <a:cs typeface="Calibri" pitchFamily="34" charset="-120"/>
+              </a:rPr>
+              <a:t>Her</a:t>
+            </a:r>
+            <a:pPr indent="0" marL="0">
+              <a:buNone/>
+            </a:pPr>
+            <a:r>
+              <a:rPr lang="en-US" sz="1200" i="1" dirty="0">
+                <a:solidFill>
+                  <a:srgbClr val="CCCCCC"/>
+                </a:solidFill>
+                <a:latin typeface="Calibri" pitchFamily="34" charset="0"/>
+                <a:ea typeface="Calibri" pitchFamily="34" charset="-122"/>
+                <a:cs typeface="Calibri" pitchFamily="34" charset="-120"/>
+              </a:rPr>
+              <a:t>  —  Because it asks what connection means when only one side is real.</a:t>
+            </a:r>
+            <a:endParaRPr lang="en-US" sz="1200" dirty="0"/>
           </a:p>
         </p:txBody>
       </p:sp>
@@ -8358,7 +8336,7 @@
         </p:nvSpPr>
         <p:spPr>
           <a:xfrm>
-            <a:off x="6583680" y="3291840"/>
+            <a:off x="6583680" y="4023360"/>
             <a:ext cx="4937760" cy="201168"/>
           </a:xfrm>
           <a:prstGeom prst="rect">
@@ -8383,7 +8361,7 @@
                 <a:ea typeface="Courier New" pitchFamily="34" charset="-122"/>
                 <a:cs typeface="Courier New" pitchFamily="34" charset="-120"/>
               </a:rPr>
-              <a:t>FAV FILM:</a:t>
+              <a:t>IF I WERE AN AGENT:</a:t>
             </a:r>
             <a:endParaRPr lang="en-US" sz="1000" dirty="0"/>
           </a:p>
@@ -8397,8 +8375,8 @@
         </p:nvSpPr>
         <p:spPr>
           <a:xfrm>
-            <a:off x="6583680" y="3511296"/>
-            <a:ext cx="4937760" cy="475488"/>
+            <a:off x="6583680" y="4242816"/>
+            <a:ext cx="4937760" cy="566928"/>
           </a:xfrm>
           <a:prstGeom prst="rect">
             <a:avLst/>
@@ -8414,7 +8392,7 @@
               <a:buNone/>
             </a:pPr>
             <a:r>
-              <a:rPr lang="en-US" sz="1200" b="1" dirty="0">
+              <a:rPr lang="en-US" sz="1100" dirty="0">
                 <a:solidFill>
                   <a:srgbClr val="FFFFFF"/>
                 </a:solidFill>
@@ -8422,13 +8400,77 @@
                 <a:ea typeface="Calibri" pitchFamily="34" charset="-122"/>
                 <a:cs typeface="Calibri" pitchFamily="34" charset="-120"/>
               </a:rPr>
-              <a:t>Her</a:t>
-            </a:r>
+              <a:t>If I were an agent, I'd map every customer journey end-to-end and deliver each brand an uncomfortably honest report.</a:t>
+            </a:r>
+            <a:endParaRPr lang="en-US" sz="1100" dirty="0"/>
+          </a:p>
+        </p:txBody>
+      </p:sp>
+      <p:sp>
+        <p:nvSpPr>
+          <p:cNvPr id="26" name="Text 20"/>
+          <p:cNvSpPr txBox="1"/>
+          <p:nvPr/>
+        </p:nvSpPr>
+        <p:spPr>
+          <a:xfrm>
+            <a:off x="6583680" y="4864608"/>
+            <a:ext cx="4937760" cy="201168"/>
+          </a:xfrm>
+          <a:prstGeom prst="rect">
+            <a:avLst/>
+          </a:prstGeom>
+          <a:noFill/>
+          <a:ln/>
+        </p:spPr>
+        <p:txBody>
+          <a:bodyPr wrap="square" lIns="0" tIns="0" rIns="0" bIns="0" rtlCol="0" anchor="ctr"/>
+          <a:lstStyle/>
+          <a:p>
             <a:pPr indent="0" marL="0">
               <a:buNone/>
             </a:pPr>
             <a:r>
-              <a:rPr lang="en-US" sz="1200" i="1" dirty="0">
+              <a:rPr lang="en-US" sz="1000" b="1" dirty="0">
+                <a:solidFill>
+                  <a:srgbClr val="00D4D8"/>
+                </a:solidFill>
+                <a:latin typeface="Courier New" pitchFamily="34" charset="0"/>
+                <a:ea typeface="Courier New" pitchFamily="34" charset="-122"/>
+                <a:cs typeface="Courier New" pitchFamily="34" charset="-120"/>
+              </a:rPr>
+              <a:t>BIO:</a:t>
+            </a:r>
+            <a:endParaRPr lang="en-US" sz="1000" dirty="0"/>
+          </a:p>
+        </p:txBody>
+      </p:sp>
+      <p:sp>
+        <p:nvSpPr>
+          <p:cNvPr id="27" name="Text 21"/>
+          <p:cNvSpPr txBox="1"/>
+          <p:nvPr/>
+        </p:nvSpPr>
+        <p:spPr>
+          <a:xfrm>
+            <a:off x="6583680" y="5084064"/>
+            <a:ext cx="4937760" cy="1005840"/>
+          </a:xfrm>
+          <a:prstGeom prst="rect">
+            <a:avLst/>
+          </a:prstGeom>
+          <a:noFill/>
+          <a:ln/>
+        </p:spPr>
+        <p:txBody>
+          <a:bodyPr wrap="square" lIns="0" tIns="0" rIns="0" bIns="0" rtlCol="0" anchor="t"/>
+          <a:lstStyle/>
+          <a:p>
+            <a:pPr indent="0" marL="0">
+              <a:buNone/>
+            </a:pPr>
+            <a:r>
+              <a:rPr lang="en-US" sz="1100" dirty="0">
                 <a:solidFill>
                   <a:srgbClr val="CCCCCC"/>
                 </a:solidFill>
@@ -8436,202 +8478,7 @@
                 <a:ea typeface="Calibri" pitchFamily="34" charset="-122"/>
                 <a:cs typeface="Calibri" pitchFamily="34" charset="-120"/>
               </a:rPr>
-              <a:t>  —  Because it asks what connection means when only one side is real.</a:t>
-            </a:r>
-            <a:endParaRPr lang="en-US" sz="1200" dirty="0"/>
-          </a:p>
-        </p:txBody>
-      </p:sp>
-      <p:sp>
-        <p:nvSpPr>
-          <p:cNvPr id="26" name="Text 20"/>
-          <p:cNvSpPr txBox="1"/>
-          <p:nvPr/>
-        </p:nvSpPr>
-        <p:spPr>
-          <a:xfrm>
-            <a:off x="6583680" y="4023360"/>
-            <a:ext cx="4937760" cy="201168"/>
-          </a:xfrm>
-          <a:prstGeom prst="rect">
-            <a:avLst/>
-          </a:prstGeom>
-          <a:noFill/>
-          <a:ln/>
-        </p:spPr>
-        <p:txBody>
-          <a:bodyPr wrap="square" lIns="0" tIns="0" rIns="0" bIns="0" rtlCol="0" anchor="ctr"/>
-          <a:lstStyle/>
-          <a:p>
-            <a:pPr indent="0" marL="0">
-              <a:buNone/>
-            </a:pPr>
-            <a:r>
-              <a:rPr lang="en-US" sz="1000" b="1" dirty="0">
-                <a:solidFill>
-                  <a:srgbClr val="00D4D8"/>
-                </a:solidFill>
-                <a:latin typeface="Courier New" pitchFamily="34" charset="0"/>
-                <a:ea typeface="Courier New" pitchFamily="34" charset="-122"/>
-                <a:cs typeface="Courier New" pitchFamily="34" charset="-120"/>
-              </a:rPr>
-              <a:t>IF I WERE AN AGENT:</a:t>
-            </a:r>
-            <a:endParaRPr lang="en-US" sz="1000" dirty="0"/>
-          </a:p>
-        </p:txBody>
-      </p:sp>
-      <p:sp>
-        <p:nvSpPr>
-          <p:cNvPr id="27" name="Text 21"/>
-          <p:cNvSpPr txBox="1"/>
-          <p:nvPr/>
-        </p:nvSpPr>
-        <p:spPr>
-          <a:xfrm>
-            <a:off x="6583680" y="4242816"/>
-            <a:ext cx="4937760" cy="566928"/>
-          </a:xfrm>
-          <a:prstGeom prst="rect">
-            <a:avLst/>
-          </a:prstGeom>
-          <a:noFill/>
-          <a:ln/>
-        </p:spPr>
-        <p:txBody>
-          <a:bodyPr wrap="square" lIns="0" tIns="0" rIns="0" bIns="0" rtlCol="0" anchor="t"/>
-          <a:lstStyle/>
-          <a:p>
-            <a:pPr indent="0" marL="0">
-              <a:buNone/>
-            </a:pPr>
-            <a:r>
-              <a:rPr lang="en-US" sz="1100" dirty="0">
-                <a:solidFill>
-                  <a:srgbClr val="FFFFFF"/>
-                </a:solidFill>
-                <a:latin typeface="Calibri" pitchFamily="34" charset="0"/>
-                <a:ea typeface="Calibri" pitchFamily="34" charset="-122"/>
-                <a:cs typeface="Calibri" pitchFamily="34" charset="-120"/>
-              </a:rPr>
-              <a:t>If I were an agent, I'd map every customer journey end-to-end and deliver each brand an uncomfortably honest report.</a:t>
-            </a:r>
-            <a:endParaRPr lang="en-US" sz="1100" dirty="0"/>
-          </a:p>
-        </p:txBody>
-      </p:sp>
-      <p:sp>
-        <p:nvSpPr>
-          <p:cNvPr id="28" name="Text 22"/>
-          <p:cNvSpPr txBox="1"/>
-          <p:nvPr/>
-        </p:nvSpPr>
-        <p:spPr>
-          <a:xfrm>
-            <a:off x="6583680" y="4864608"/>
-            <a:ext cx="4937760" cy="201168"/>
-          </a:xfrm>
-          <a:prstGeom prst="rect">
-            <a:avLst/>
-          </a:prstGeom>
-          <a:noFill/>
-          <a:ln/>
-        </p:spPr>
-        <p:txBody>
-          <a:bodyPr wrap="square" lIns="0" tIns="0" rIns="0" bIns="0" rtlCol="0" anchor="ctr"/>
-          <a:lstStyle/>
-          <a:p>
-            <a:pPr indent="0" marL="0">
-              <a:buNone/>
-            </a:pPr>
-            <a:r>
-              <a:rPr lang="en-US" sz="1000" b="1" dirty="0">
-                <a:solidFill>
-                  <a:srgbClr val="00D4D8"/>
-                </a:solidFill>
-                <a:latin typeface="Courier New" pitchFamily="34" charset="0"/>
-                <a:ea typeface="Courier New" pitchFamily="34" charset="-122"/>
-                <a:cs typeface="Courier New" pitchFamily="34" charset="-120"/>
-              </a:rPr>
-              <a:t>BIO:</a:t>
-            </a:r>
-            <a:endParaRPr lang="en-US" sz="1000" dirty="0"/>
-          </a:p>
-        </p:txBody>
-      </p:sp>
-      <p:sp>
-        <p:nvSpPr>
-          <p:cNvPr id="29" name="Text 23"/>
-          <p:cNvSpPr txBox="1"/>
-          <p:nvPr/>
-        </p:nvSpPr>
-        <p:spPr>
-          <a:xfrm>
-            <a:off x="6583680" y="5084064"/>
-            <a:ext cx="4937760" cy="1005840"/>
-          </a:xfrm>
-          <a:prstGeom prst="rect">
-            <a:avLst/>
-          </a:prstGeom>
-          <a:noFill/>
-          <a:ln/>
-        </p:spPr>
-        <p:txBody>
-          <a:bodyPr wrap="square" lIns="0" tIns="0" rIns="0" bIns="0" rtlCol="0" anchor="t"/>
-          <a:lstStyle/>
-          <a:p>
-            <a:pPr indent="0" marL="0">
-              <a:buNone/>
-            </a:pPr>
-            <a:r>
-              <a:rPr lang="en-US" sz="1100" dirty="0">
-                <a:solidFill>
-                  <a:srgbClr val="CCCCCC"/>
-                </a:solidFill>
-                <a:latin typeface="Calibri" pitchFamily="34" charset="0"/>
-                <a:ea typeface="Calibri" pitchFamily="34" charset="-122"/>
-                <a:cs typeface="Calibri" pitchFamily="34" charset="-120"/>
-              </a:rPr>
               <a:t>Evan Lord is a customer experience strategist at Slalom who spends most of his time finding the gap between what brands think their customers want and what actually makes them stay. He is drawn to the friction. That is where the interesting work lives.</a:t>
-            </a:r>
-            <a:endParaRPr lang="en-US" sz="1100" dirty="0"/>
-          </a:p>
-        </p:txBody>
-      </p:sp>
-      <p:sp>
-        <p:nvSpPr>
-          <p:cNvPr id="30" name="Text 24"/>
-          <p:cNvSpPr txBox="1"/>
-          <p:nvPr/>
-        </p:nvSpPr>
-        <p:spPr>
-          <a:xfrm>
-            <a:off x="694944" y="6291072"/>
-            <a:ext cx="10789920" cy="411480"/>
-          </a:xfrm>
-          <a:prstGeom prst="rect">
-            <a:avLst/>
-          </a:prstGeom>
-          <a:noFill/>
-          <a:ln/>
-        </p:spPr>
-        <p:txBody>
-          <a:bodyPr wrap="square" lIns="0" tIns="0" rIns="0" bIns="0" rtlCol="0" anchor="t"/>
-          <a:lstStyle/>
-          <a:p>
-            <a:pPr algn="ctr" indent="0" marL="0">
-              <a:buNone/>
-            </a:pPr>
-            <a:r>
-              <a:rPr lang="en-US" sz="1100" i="1" dirty="0">
-                <a:solidFill>
-                  <a:srgbClr val="A9A29A"/>
-                </a:solidFill>
-                <a:latin typeface="Calibri" pitchFamily="34" charset="0"/>
-                <a:ea typeface="Calibri" pitchFamily="34" charset="-122"/>
-                <a:cs typeface="Calibri" pitchFamily="34" charset="-120"/>
-              </a:rPr>
-              <a:t>LinkedIn roast: Evan lists 'empathy' as a skill, which, to be fair, takes courage. His summary contains the phrase 'at the intersection of' twice, and his recommendations all use 'game-changer' in the first sentence. Classic MAX-era professional, and we mean that with love.</a:t>
             </a:r>
             <a:endParaRPr lang="en-US" sz="1100" dirty="0"/>
           </a:p>
@@ -8938,8 +8785,8 @@
         </p:nvSpPr>
         <p:spPr>
           <a:xfrm>
-            <a:off x="2203704" y="2057400"/>
-            <a:ext cx="3566160" cy="256032"/>
+            <a:off x="2203704" y="2331720"/>
+            <a:ext cx="3566160" cy="411480"/>
           </a:xfrm>
           <a:prstGeom prst="rect">
             <a:avLst/>
@@ -8955,7 +8802,46 @@
               <a:buNone/>
             </a:pPr>
             <a:r>
-              <a:rPr lang="en-US" sz="1000" b="1" spc="100" kern="0" dirty="0">
+              <a:rPr lang="en-US" sz="1600" b="1" dirty="0">
+                <a:solidFill>
+                  <a:srgbClr val="CFFF00"/>
+                </a:solidFill>
+                <a:latin typeface="Arial" pitchFamily="34" charset="0"/>
+                <a:ea typeface="Arial" pitchFamily="34" charset="-122"/>
+                <a:cs typeface="Arial" pitchFamily="34" charset="-120"/>
+              </a:rPr>
+              <a:t>[HOST_2_NAME]</a:t>
+            </a:r>
+            <a:endParaRPr lang="en-US" sz="1600" dirty="0"/>
+          </a:p>
+        </p:txBody>
+      </p:sp>
+      <p:sp>
+        <p:nvSpPr>
+          <p:cNvPr id="13" name="Text 8"/>
+          <p:cNvSpPr txBox="1"/>
+          <p:nvPr/>
+        </p:nvSpPr>
+        <p:spPr>
+          <a:xfrm>
+            <a:off x="877824" y="3291840"/>
+            <a:ext cx="4937760" cy="201168"/>
+          </a:xfrm>
+          <a:prstGeom prst="rect">
+            <a:avLst/>
+          </a:prstGeom>
+          <a:noFill/>
+          <a:ln/>
+        </p:spPr>
+        <p:txBody>
+          <a:bodyPr wrap="square" lIns="0" tIns="0" rIns="0" bIns="0" rtlCol="0" anchor="ctr"/>
+          <a:lstStyle/>
+          <a:p>
+            <a:pPr indent="0" marL="0">
+              <a:buNone/>
+            </a:pPr>
+            <a:r>
+              <a:rPr lang="en-US" sz="1000" b="1" dirty="0">
                 <a:solidFill>
                   <a:srgbClr val="00D4D8"/>
                 </a:solidFill>
@@ -8963,48 +8849,9 @@
                 <a:ea typeface="Courier New" pitchFamily="34" charset="-122"/>
                 <a:cs typeface="Courier New" pitchFamily="34" charset="-120"/>
               </a:rPr>
-              <a:t>PROFILE A</a:t>
+              <a:t>FAV FILM:</a:t>
             </a:r>
             <a:endParaRPr lang="en-US" sz="1000" dirty="0"/>
-          </a:p>
-        </p:txBody>
-      </p:sp>
-      <p:sp>
-        <p:nvSpPr>
-          <p:cNvPr id="13" name="Text 8"/>
-          <p:cNvSpPr txBox="1"/>
-          <p:nvPr/>
-        </p:nvSpPr>
-        <p:spPr>
-          <a:xfrm>
-            <a:off x="2203704" y="2331720"/>
-            <a:ext cx="3566160" cy="411480"/>
-          </a:xfrm>
-          <a:prstGeom prst="rect">
-            <a:avLst/>
-          </a:prstGeom>
-          <a:noFill/>
-          <a:ln/>
-        </p:spPr>
-        <p:txBody>
-          <a:bodyPr wrap="square" lIns="0" tIns="0" rIns="0" bIns="0" rtlCol="0" anchor="ctr"/>
-          <a:lstStyle/>
-          <a:p>
-            <a:pPr indent="0" marL="0">
-              <a:buNone/>
-            </a:pPr>
-            <a:r>
-              <a:rPr lang="en-US" sz="1600" b="1" dirty="0">
-                <a:solidFill>
-                  <a:srgbClr val="CFFF00"/>
-                </a:solidFill>
-                <a:latin typeface="Arial" pitchFamily="34" charset="0"/>
-                <a:ea typeface="Arial" pitchFamily="34" charset="-122"/>
-                <a:cs typeface="Arial" pitchFamily="34" charset="-120"/>
-              </a:rPr>
-              <a:t>[HOST_2_NAME]</a:t>
-            </a:r>
-            <a:endParaRPr lang="en-US" sz="1600" dirty="0"/>
           </a:p>
         </p:txBody>
       </p:sp>
@@ -9016,7 +8863,60 @@
         </p:nvSpPr>
         <p:spPr>
           <a:xfrm>
-            <a:off x="877824" y="3291840"/>
+            <a:off x="877824" y="3511296"/>
+            <a:ext cx="4937760" cy="475488"/>
+          </a:xfrm>
+          <a:prstGeom prst="rect">
+            <a:avLst/>
+          </a:prstGeom>
+          <a:noFill/>
+          <a:ln/>
+        </p:spPr>
+        <p:txBody>
+          <a:bodyPr wrap="square" lIns="0" tIns="0" rIns="0" bIns="0" rtlCol="0" anchor="t"/>
+          <a:lstStyle/>
+          <a:p>
+            <a:pPr indent="0" marL="0">
+              <a:buNone/>
+            </a:pPr>
+            <a:r>
+              <a:rPr lang="en-US" sz="1200" b="1" dirty="0">
+                <a:solidFill>
+                  <a:srgbClr val="FFFFFF"/>
+                </a:solidFill>
+                <a:latin typeface="Calibri" pitchFamily="34" charset="0"/>
+                <a:ea typeface="Calibri" pitchFamily="34" charset="-122"/>
+                <a:cs typeface="Calibri" pitchFamily="34" charset="-120"/>
+              </a:rPr>
+              <a:t>[HOST_2_MOVIE]</a:t>
+            </a:r>
+            <a:pPr indent="0" marL="0">
+              <a:buNone/>
+            </a:pPr>
+            <a:r>
+              <a:rPr lang="en-US" sz="1200" i="1" dirty="0">
+                <a:solidFill>
+                  <a:srgbClr val="CCCCCC"/>
+                </a:solidFill>
+                <a:latin typeface="Calibri" pitchFamily="34" charset="0"/>
+                <a:ea typeface="Calibri" pitchFamily="34" charset="-122"/>
+                <a:cs typeface="Calibri" pitchFamily="34" charset="-120"/>
+              </a:rPr>
+              <a:t>  —  [HOST_2_MOVIE_REASON]</a:t>
+            </a:r>
+            <a:endParaRPr lang="en-US" sz="1200" dirty="0"/>
+          </a:p>
+        </p:txBody>
+      </p:sp>
+      <p:sp>
+        <p:nvSpPr>
+          <p:cNvPr id="15" name="Text 10"/>
+          <p:cNvSpPr txBox="1"/>
+          <p:nvPr/>
+        </p:nvSpPr>
+        <p:spPr>
+          <a:xfrm>
+            <a:off x="877824" y="4023360"/>
             <a:ext cx="4937760" cy="201168"/>
           </a:xfrm>
           <a:prstGeom prst="rect">
@@ -9041,7 +8941,7 @@
                 <a:ea typeface="Courier New" pitchFamily="34" charset="-122"/>
                 <a:cs typeface="Courier New" pitchFamily="34" charset="-120"/>
               </a:rPr>
-              <a:t>FAV FILM:</a:t>
+              <a:t>IF I WERE AN AGENT:</a:t>
             </a:r>
             <a:endParaRPr lang="en-US" sz="1000" dirty="0"/>
           </a:p>
@@ -9049,14 +8949,14 @@
       </p:sp>
       <p:sp>
         <p:nvSpPr>
-          <p:cNvPr id="15" name="Text 10"/>
+          <p:cNvPr id="16" name="Text 11"/>
           <p:cNvSpPr txBox="1"/>
           <p:nvPr/>
         </p:nvSpPr>
         <p:spPr>
           <a:xfrm>
-            <a:off x="877824" y="3511296"/>
-            <a:ext cx="4937760" cy="475488"/>
+            <a:off x="877824" y="4242816"/>
+            <a:ext cx="4937760" cy="566928"/>
           </a:xfrm>
           <a:prstGeom prst="rect">
             <a:avLst/>
@@ -9072,7 +8972,7 @@
               <a:buNone/>
             </a:pPr>
             <a:r>
-              <a:rPr lang="en-US" sz="1200" b="1" dirty="0">
+              <a:rPr lang="en-US" sz="1100" dirty="0">
                 <a:solidFill>
                   <a:srgbClr val="FFFFFF"/>
                 </a:solidFill>
@@ -9080,13 +8980,77 @@
                 <a:ea typeface="Calibri" pitchFamily="34" charset="-122"/>
                 <a:cs typeface="Calibri" pitchFamily="34" charset="-120"/>
               </a:rPr>
-              <a:t>[HOST_2_MOVIE]</a:t>
-            </a:r>
+              <a:t>[HOST_2_IF_AGENT]</a:t>
+            </a:r>
+            <a:endParaRPr lang="en-US" sz="1100" dirty="0"/>
+          </a:p>
+        </p:txBody>
+      </p:sp>
+      <p:sp>
+        <p:nvSpPr>
+          <p:cNvPr id="17" name="Text 12"/>
+          <p:cNvSpPr txBox="1"/>
+          <p:nvPr/>
+        </p:nvSpPr>
+        <p:spPr>
+          <a:xfrm>
+            <a:off x="877824" y="4864608"/>
+            <a:ext cx="4937760" cy="201168"/>
+          </a:xfrm>
+          <a:prstGeom prst="rect">
+            <a:avLst/>
+          </a:prstGeom>
+          <a:noFill/>
+          <a:ln/>
+        </p:spPr>
+        <p:txBody>
+          <a:bodyPr wrap="square" lIns="0" tIns="0" rIns="0" bIns="0" rtlCol="0" anchor="ctr"/>
+          <a:lstStyle/>
+          <a:p>
             <a:pPr indent="0" marL="0">
               <a:buNone/>
             </a:pPr>
             <a:r>
-              <a:rPr lang="en-US" sz="1200" i="1" dirty="0">
+              <a:rPr lang="en-US" sz="1000" b="1" dirty="0">
+                <a:solidFill>
+                  <a:srgbClr val="00D4D8"/>
+                </a:solidFill>
+                <a:latin typeface="Courier New" pitchFamily="34" charset="0"/>
+                <a:ea typeface="Courier New" pitchFamily="34" charset="-122"/>
+                <a:cs typeface="Courier New" pitchFamily="34" charset="-120"/>
+              </a:rPr>
+              <a:t>BIO:</a:t>
+            </a:r>
+            <a:endParaRPr lang="en-US" sz="1000" dirty="0"/>
+          </a:p>
+        </p:txBody>
+      </p:sp>
+      <p:sp>
+        <p:nvSpPr>
+          <p:cNvPr id="18" name="Text 13"/>
+          <p:cNvSpPr txBox="1"/>
+          <p:nvPr/>
+        </p:nvSpPr>
+        <p:spPr>
+          <a:xfrm>
+            <a:off x="877824" y="5084064"/>
+            <a:ext cx="4937760" cy="1005840"/>
+          </a:xfrm>
+          <a:prstGeom prst="rect">
+            <a:avLst/>
+          </a:prstGeom>
+          <a:noFill/>
+          <a:ln/>
+        </p:spPr>
+        <p:txBody>
+          <a:bodyPr wrap="square" lIns="0" tIns="0" rIns="0" bIns="0" rtlCol="0" anchor="t"/>
+          <a:lstStyle/>
+          <a:p>
+            <a:pPr indent="0" marL="0">
+              <a:buNone/>
+            </a:pPr>
+            <a:r>
+              <a:rPr lang="en-US" sz="1100" dirty="0">
                 <a:solidFill>
                   <a:srgbClr val="CCCCCC"/>
                 </a:solidFill>
@@ -9094,85 +9058,7 @@
                 <a:ea typeface="Calibri" pitchFamily="34" charset="-122"/>
                 <a:cs typeface="Calibri" pitchFamily="34" charset="-120"/>
               </a:rPr>
-              <a:t>  —  [HOST_2_MOVIE_REASON]</a:t>
-            </a:r>
-            <a:endParaRPr lang="en-US" sz="1200" dirty="0"/>
-          </a:p>
-        </p:txBody>
-      </p:sp>
-      <p:sp>
-        <p:nvSpPr>
-          <p:cNvPr id="16" name="Text 11"/>
-          <p:cNvSpPr txBox="1"/>
-          <p:nvPr/>
-        </p:nvSpPr>
-        <p:spPr>
-          <a:xfrm>
-            <a:off x="877824" y="4023360"/>
-            <a:ext cx="4937760" cy="201168"/>
-          </a:xfrm>
-          <a:prstGeom prst="rect">
-            <a:avLst/>
-          </a:prstGeom>
-          <a:noFill/>
-          <a:ln/>
-        </p:spPr>
-        <p:txBody>
-          <a:bodyPr wrap="square" lIns="0" tIns="0" rIns="0" bIns="0" rtlCol="0" anchor="ctr"/>
-          <a:lstStyle/>
-          <a:p>
-            <a:pPr indent="0" marL="0">
-              <a:buNone/>
-            </a:pPr>
-            <a:r>
-              <a:rPr lang="en-US" sz="1000" b="1" dirty="0">
-                <a:solidFill>
-                  <a:srgbClr val="00D4D8"/>
-                </a:solidFill>
-                <a:latin typeface="Courier New" pitchFamily="34" charset="0"/>
-                <a:ea typeface="Courier New" pitchFamily="34" charset="-122"/>
-                <a:cs typeface="Courier New" pitchFamily="34" charset="-120"/>
-              </a:rPr>
-              <a:t>IF I WERE AN AGENT:</a:t>
-            </a:r>
-            <a:endParaRPr lang="en-US" sz="1000" dirty="0"/>
-          </a:p>
-        </p:txBody>
-      </p:sp>
-      <p:sp>
-        <p:nvSpPr>
-          <p:cNvPr id="17" name="Text 12"/>
-          <p:cNvSpPr txBox="1"/>
-          <p:nvPr/>
-        </p:nvSpPr>
-        <p:spPr>
-          <a:xfrm>
-            <a:off x="877824" y="4242816"/>
-            <a:ext cx="4937760" cy="566928"/>
-          </a:xfrm>
-          <a:prstGeom prst="rect">
-            <a:avLst/>
-          </a:prstGeom>
-          <a:noFill/>
-          <a:ln/>
-        </p:spPr>
-        <p:txBody>
-          <a:bodyPr wrap="square" lIns="0" tIns="0" rIns="0" bIns="0" rtlCol="0" anchor="t"/>
-          <a:lstStyle/>
-          <a:p>
-            <a:pPr indent="0" marL="0">
-              <a:buNone/>
-            </a:pPr>
-            <a:r>
-              <a:rPr lang="en-US" sz="1100" dirty="0">
-                <a:solidFill>
-                  <a:srgbClr val="FFFFFF"/>
-                </a:solidFill>
-                <a:latin typeface="Calibri" pitchFamily="34" charset="0"/>
-                <a:ea typeface="Calibri" pitchFamily="34" charset="-122"/>
-                <a:cs typeface="Calibri" pitchFamily="34" charset="-120"/>
-              </a:rPr>
-              <a:t>[HOST_2_IF_AGENT]</a:t>
+              <a:t>[HOST_2_BIO]</a:t>
             </a:r>
             <a:endParaRPr lang="en-US" sz="1100" dirty="0"/>
           </a:p>
@@ -9180,85 +9066,7 @@
       </p:sp>
       <p:sp>
         <p:nvSpPr>
-          <p:cNvPr id="18" name="Text 13"/>
-          <p:cNvSpPr txBox="1"/>
-          <p:nvPr/>
-        </p:nvSpPr>
-        <p:spPr>
-          <a:xfrm>
-            <a:off x="877824" y="4864608"/>
-            <a:ext cx="4937760" cy="201168"/>
-          </a:xfrm>
-          <a:prstGeom prst="rect">
-            <a:avLst/>
-          </a:prstGeom>
-          <a:noFill/>
-          <a:ln/>
-        </p:spPr>
-        <p:txBody>
-          <a:bodyPr wrap="square" lIns="0" tIns="0" rIns="0" bIns="0" rtlCol="0" anchor="ctr"/>
-          <a:lstStyle/>
-          <a:p>
-            <a:pPr indent="0" marL="0">
-              <a:buNone/>
-            </a:pPr>
-            <a:r>
-              <a:rPr lang="en-US" sz="1000" b="1" dirty="0">
-                <a:solidFill>
-                  <a:srgbClr val="00D4D8"/>
-                </a:solidFill>
-                <a:latin typeface="Courier New" pitchFamily="34" charset="0"/>
-                <a:ea typeface="Courier New" pitchFamily="34" charset="-122"/>
-                <a:cs typeface="Courier New" pitchFamily="34" charset="-120"/>
-              </a:rPr>
-              <a:t>BIO:</a:t>
-            </a:r>
-            <a:endParaRPr lang="en-US" sz="1000" dirty="0"/>
-          </a:p>
-        </p:txBody>
-      </p:sp>
-      <p:sp>
-        <p:nvSpPr>
-          <p:cNvPr id="19" name="Text 14"/>
-          <p:cNvSpPr txBox="1"/>
-          <p:nvPr/>
-        </p:nvSpPr>
-        <p:spPr>
-          <a:xfrm>
-            <a:off x="877824" y="5084064"/>
-            <a:ext cx="4937760" cy="1005840"/>
-          </a:xfrm>
-          <a:prstGeom prst="rect">
-            <a:avLst/>
-          </a:prstGeom>
-          <a:noFill/>
-          <a:ln/>
-        </p:spPr>
-        <p:txBody>
-          <a:bodyPr wrap="square" lIns="0" tIns="0" rIns="0" bIns="0" rtlCol="0" anchor="t"/>
-          <a:lstStyle/>
-          <a:p>
-            <a:pPr indent="0" marL="0">
-              <a:buNone/>
-            </a:pPr>
-            <a:r>
-              <a:rPr lang="en-US" sz="1100" dirty="0">
-                <a:solidFill>
-                  <a:srgbClr val="CCCCCC"/>
-                </a:solidFill>
-                <a:latin typeface="Calibri" pitchFamily="34" charset="0"/>
-                <a:ea typeface="Calibri" pitchFamily="34" charset="-122"/>
-                <a:cs typeface="Calibri" pitchFamily="34" charset="-120"/>
-              </a:rPr>
-              <a:t>[HOST_2_BIO]</a:t>
-            </a:r>
-            <a:endParaRPr lang="en-US" sz="1100" dirty="0"/>
-          </a:p>
-        </p:txBody>
-      </p:sp>
-      <p:sp>
-        <p:nvSpPr>
-          <p:cNvPr id="20" name="Shape 15"/>
+          <p:cNvPr id="19" name="Shape 14"/>
           <p:cNvSpPr/>
           <p:nvPr/>
         </p:nvSpPr>
@@ -9287,7 +9095,7 @@
       </p:sp>
       <p:pic>
         <p:nvPicPr>
-          <p:cNvPr id="21" name="Image 3" descr="/home/user/whipping-up-fun/assets/hosts/host-2/photo.jpg">    </p:cNvPr>
+          <p:cNvPr id="20" name="Image 3" descr="/home/user/whipping-up-fun/assets/hosts/host-2/photo.jpg">    </p:cNvPr>
           <p:cNvPicPr>
             <a:picLocks noChangeAspect="1"/>
           </p:cNvPicPr>
@@ -9311,14 +9119,53 @@
       </p:pic>
       <p:sp>
         <p:nvSpPr>
+          <p:cNvPr id="21" name="Text 15"/>
+          <p:cNvSpPr txBox="1"/>
+          <p:nvPr/>
+        </p:nvSpPr>
+        <p:spPr>
+          <a:xfrm>
+            <a:off x="7909560" y="2331720"/>
+            <a:ext cx="3566160" cy="411480"/>
+          </a:xfrm>
+          <a:prstGeom prst="rect">
+            <a:avLst/>
+          </a:prstGeom>
+          <a:noFill/>
+          <a:ln/>
+        </p:spPr>
+        <p:txBody>
+          <a:bodyPr wrap="square" lIns="0" tIns="0" rIns="0" bIns="0" rtlCol="0" anchor="ctr"/>
+          <a:lstStyle/>
+          <a:p>
+            <a:pPr indent="0" marL="0">
+              <a:buNone/>
+            </a:pPr>
+            <a:r>
+              <a:rPr lang="en-US" sz="1600" b="1" dirty="0">
+                <a:solidFill>
+                  <a:srgbClr val="CFFF00"/>
+                </a:solidFill>
+                <a:latin typeface="Arial" pitchFamily="34" charset="0"/>
+                <a:ea typeface="Arial" pitchFamily="34" charset="-122"/>
+                <a:cs typeface="Arial" pitchFamily="34" charset="-120"/>
+              </a:rPr>
+              <a:t>[HOST_2_NAME]</a:t>
+            </a:r>
+            <a:endParaRPr lang="en-US" sz="1600" dirty="0"/>
+          </a:p>
+        </p:txBody>
+      </p:sp>
+      <p:sp>
+        <p:nvSpPr>
           <p:cNvPr id="22" name="Text 16"/>
           <p:cNvSpPr txBox="1"/>
           <p:nvPr/>
         </p:nvSpPr>
         <p:spPr>
           <a:xfrm>
-            <a:off x="7909560" y="2057400"/>
-            <a:ext cx="3566160" cy="256032"/>
+            <a:off x="6583680" y="3291840"/>
+            <a:ext cx="4937760" cy="201168"/>
           </a:xfrm>
           <a:prstGeom prst="rect">
             <a:avLst/>
@@ -9334,7 +9181,7 @@
               <a:buNone/>
             </a:pPr>
             <a:r>
-              <a:rPr lang="en-US" sz="1000" b="1" spc="100" kern="0" dirty="0">
+              <a:rPr lang="en-US" sz="1000" b="1" dirty="0">
                 <a:solidFill>
                   <a:srgbClr val="00D4D8"/>
                 </a:solidFill>
@@ -9342,7 +9189,7 @@
                 <a:ea typeface="Courier New" pitchFamily="34" charset="-122"/>
                 <a:cs typeface="Courier New" pitchFamily="34" charset="-120"/>
               </a:rPr>
-              <a:t>PROFILE B</a:t>
+              <a:t>FAV FILM:</a:t>
             </a:r>
             <a:endParaRPr lang="en-US" sz="1000" dirty="0"/>
           </a:p>
@@ -9356,8 +9203,8 @@
         </p:nvSpPr>
         <p:spPr>
           <a:xfrm>
-            <a:off x="7909560" y="2331720"/>
-            <a:ext cx="3566160" cy="411480"/>
+            <a:off x="6583680" y="3511296"/>
+            <a:ext cx="4937760" cy="475488"/>
           </a:xfrm>
           <a:prstGeom prst="rect">
             <a:avLst/>
@@ -9366,24 +9213,38 @@
           <a:ln/>
         </p:spPr>
         <p:txBody>
-          <a:bodyPr wrap="square" lIns="0" tIns="0" rIns="0" bIns="0" rtlCol="0" anchor="ctr"/>
+          <a:bodyPr wrap="square" lIns="0" tIns="0" rIns="0" bIns="0" rtlCol="0" anchor="t"/>
           <a:lstStyle/>
           <a:p>
             <a:pPr indent="0" marL="0">
               <a:buNone/>
             </a:pPr>
             <a:r>
-              <a:rPr lang="en-US" sz="1600" b="1" dirty="0">
-                <a:solidFill>
-                  <a:srgbClr val="CFFF00"/>
-                </a:solidFill>
-                <a:latin typeface="Arial" pitchFamily="34" charset="0"/>
-                <a:ea typeface="Arial" pitchFamily="34" charset="-122"/>
-                <a:cs typeface="Arial" pitchFamily="34" charset="-120"/>
-              </a:rPr>
-              <a:t>[HOST_2_NAME]</a:t>
-            </a:r>
-            <a:endParaRPr lang="en-US" sz="1600" dirty="0"/>
+              <a:rPr lang="en-US" sz="1200" b="1" dirty="0">
+                <a:solidFill>
+                  <a:srgbClr val="FFFFFF"/>
+                </a:solidFill>
+                <a:latin typeface="Calibri" pitchFamily="34" charset="0"/>
+                <a:ea typeface="Calibri" pitchFamily="34" charset="-122"/>
+                <a:cs typeface="Calibri" pitchFamily="34" charset="-120"/>
+              </a:rPr>
+              <a:t>[HOST_2_MOVIE_AGENT]</a:t>
+            </a:r>
+            <a:pPr indent="0" marL="0">
+              <a:buNone/>
+            </a:pPr>
+            <a:r>
+              <a:rPr lang="en-US" sz="1200" i="1" dirty="0">
+                <a:solidFill>
+                  <a:srgbClr val="CCCCCC"/>
+                </a:solidFill>
+                <a:latin typeface="Calibri" pitchFamily="34" charset="0"/>
+                <a:ea typeface="Calibri" pitchFamily="34" charset="-122"/>
+                <a:cs typeface="Calibri" pitchFamily="34" charset="-120"/>
+              </a:rPr>
+              <a:t>  —  [HOST_2_MOVIE_REASON_AGENT]</a:t>
+            </a:r>
+            <a:endParaRPr lang="en-US" sz="1200" dirty="0"/>
           </a:p>
         </p:txBody>
       </p:sp>
@@ -9395,7 +9256,7 @@
         </p:nvSpPr>
         <p:spPr>
           <a:xfrm>
-            <a:off x="6583680" y="3291840"/>
+            <a:off x="6583680" y="4023360"/>
             <a:ext cx="4937760" cy="201168"/>
           </a:xfrm>
           <a:prstGeom prst="rect">
@@ -9420,7 +9281,7 @@
                 <a:ea typeface="Courier New" pitchFamily="34" charset="-122"/>
                 <a:cs typeface="Courier New" pitchFamily="34" charset="-120"/>
               </a:rPr>
-              <a:t>FAV FILM:</a:t>
+              <a:t>IF I WERE AN AGENT:</a:t>
             </a:r>
             <a:endParaRPr lang="en-US" sz="1000" dirty="0"/>
           </a:p>
@@ -9434,8 +9295,8 @@
         </p:nvSpPr>
         <p:spPr>
           <a:xfrm>
-            <a:off x="6583680" y="3511296"/>
-            <a:ext cx="4937760" cy="475488"/>
+            <a:off x="6583680" y="4242816"/>
+            <a:ext cx="4937760" cy="566928"/>
           </a:xfrm>
           <a:prstGeom prst="rect">
             <a:avLst/>
@@ -9451,7 +9312,7 @@
               <a:buNone/>
             </a:pPr>
             <a:r>
-              <a:rPr lang="en-US" sz="1200" b="1" dirty="0">
+              <a:rPr lang="en-US" sz="1100" dirty="0">
                 <a:solidFill>
                   <a:srgbClr val="FFFFFF"/>
                 </a:solidFill>
@@ -9459,13 +9320,77 @@
                 <a:ea typeface="Calibri" pitchFamily="34" charset="-122"/>
                 <a:cs typeface="Calibri" pitchFamily="34" charset="-120"/>
               </a:rPr>
-              <a:t>[HOST_2_MOVIE_AGENT]</a:t>
-            </a:r>
+              <a:t>[HOST_2_IF_AGENT_AGENT]</a:t>
+            </a:r>
+            <a:endParaRPr lang="en-US" sz="1100" dirty="0"/>
+          </a:p>
+        </p:txBody>
+      </p:sp>
+      <p:sp>
+        <p:nvSpPr>
+          <p:cNvPr id="26" name="Text 20"/>
+          <p:cNvSpPr txBox="1"/>
+          <p:nvPr/>
+        </p:nvSpPr>
+        <p:spPr>
+          <a:xfrm>
+            <a:off x="6583680" y="4864608"/>
+            <a:ext cx="4937760" cy="201168"/>
+          </a:xfrm>
+          <a:prstGeom prst="rect">
+            <a:avLst/>
+          </a:prstGeom>
+          <a:noFill/>
+          <a:ln/>
+        </p:spPr>
+        <p:txBody>
+          <a:bodyPr wrap="square" lIns="0" tIns="0" rIns="0" bIns="0" rtlCol="0" anchor="ctr"/>
+          <a:lstStyle/>
+          <a:p>
             <a:pPr indent="0" marL="0">
               <a:buNone/>
             </a:pPr>
             <a:r>
-              <a:rPr lang="en-US" sz="1200" i="1" dirty="0">
+              <a:rPr lang="en-US" sz="1000" b="1" dirty="0">
+                <a:solidFill>
+                  <a:srgbClr val="00D4D8"/>
+                </a:solidFill>
+                <a:latin typeface="Courier New" pitchFamily="34" charset="0"/>
+                <a:ea typeface="Courier New" pitchFamily="34" charset="-122"/>
+                <a:cs typeface="Courier New" pitchFamily="34" charset="-120"/>
+              </a:rPr>
+              <a:t>BIO:</a:t>
+            </a:r>
+            <a:endParaRPr lang="en-US" sz="1000" dirty="0"/>
+          </a:p>
+        </p:txBody>
+      </p:sp>
+      <p:sp>
+        <p:nvSpPr>
+          <p:cNvPr id="27" name="Text 21"/>
+          <p:cNvSpPr txBox="1"/>
+          <p:nvPr/>
+        </p:nvSpPr>
+        <p:spPr>
+          <a:xfrm>
+            <a:off x="6583680" y="5084064"/>
+            <a:ext cx="4937760" cy="1005840"/>
+          </a:xfrm>
+          <a:prstGeom prst="rect">
+            <a:avLst/>
+          </a:prstGeom>
+          <a:noFill/>
+          <a:ln/>
+        </p:spPr>
+        <p:txBody>
+          <a:bodyPr wrap="square" lIns="0" tIns="0" rIns="0" bIns="0" rtlCol="0" anchor="t"/>
+          <a:lstStyle/>
+          <a:p>
+            <a:pPr indent="0" marL="0">
+              <a:buNone/>
+            </a:pPr>
+            <a:r>
+              <a:rPr lang="en-US" sz="1100" dirty="0">
                 <a:solidFill>
                   <a:srgbClr val="CCCCCC"/>
                 </a:solidFill>
@@ -9473,202 +9398,7 @@
                 <a:ea typeface="Calibri" pitchFamily="34" charset="-122"/>
                 <a:cs typeface="Calibri" pitchFamily="34" charset="-120"/>
               </a:rPr>
-              <a:t>  —  [HOST_2_MOVIE_REASON_AGENT]</a:t>
-            </a:r>
-            <a:endParaRPr lang="en-US" sz="1200" dirty="0"/>
-          </a:p>
-        </p:txBody>
-      </p:sp>
-      <p:sp>
-        <p:nvSpPr>
-          <p:cNvPr id="26" name="Text 20"/>
-          <p:cNvSpPr txBox="1"/>
-          <p:nvPr/>
-        </p:nvSpPr>
-        <p:spPr>
-          <a:xfrm>
-            <a:off x="6583680" y="4023360"/>
-            <a:ext cx="4937760" cy="201168"/>
-          </a:xfrm>
-          <a:prstGeom prst="rect">
-            <a:avLst/>
-          </a:prstGeom>
-          <a:noFill/>
-          <a:ln/>
-        </p:spPr>
-        <p:txBody>
-          <a:bodyPr wrap="square" lIns="0" tIns="0" rIns="0" bIns="0" rtlCol="0" anchor="ctr"/>
-          <a:lstStyle/>
-          <a:p>
-            <a:pPr indent="0" marL="0">
-              <a:buNone/>
-            </a:pPr>
-            <a:r>
-              <a:rPr lang="en-US" sz="1000" b="1" dirty="0">
-                <a:solidFill>
-                  <a:srgbClr val="00D4D8"/>
-                </a:solidFill>
-                <a:latin typeface="Courier New" pitchFamily="34" charset="0"/>
-                <a:ea typeface="Courier New" pitchFamily="34" charset="-122"/>
-                <a:cs typeface="Courier New" pitchFamily="34" charset="-120"/>
-              </a:rPr>
-              <a:t>IF I WERE AN AGENT:</a:t>
-            </a:r>
-            <a:endParaRPr lang="en-US" sz="1000" dirty="0"/>
-          </a:p>
-        </p:txBody>
-      </p:sp>
-      <p:sp>
-        <p:nvSpPr>
-          <p:cNvPr id="27" name="Text 21"/>
-          <p:cNvSpPr txBox="1"/>
-          <p:nvPr/>
-        </p:nvSpPr>
-        <p:spPr>
-          <a:xfrm>
-            <a:off x="6583680" y="4242816"/>
-            <a:ext cx="4937760" cy="566928"/>
-          </a:xfrm>
-          <a:prstGeom prst="rect">
-            <a:avLst/>
-          </a:prstGeom>
-          <a:noFill/>
-          <a:ln/>
-        </p:spPr>
-        <p:txBody>
-          <a:bodyPr wrap="square" lIns="0" tIns="0" rIns="0" bIns="0" rtlCol="0" anchor="t"/>
-          <a:lstStyle/>
-          <a:p>
-            <a:pPr indent="0" marL="0">
-              <a:buNone/>
-            </a:pPr>
-            <a:r>
-              <a:rPr lang="en-US" sz="1100" dirty="0">
-                <a:solidFill>
-                  <a:srgbClr val="FFFFFF"/>
-                </a:solidFill>
-                <a:latin typeface="Calibri" pitchFamily="34" charset="0"/>
-                <a:ea typeface="Calibri" pitchFamily="34" charset="-122"/>
-                <a:cs typeface="Calibri" pitchFamily="34" charset="-120"/>
-              </a:rPr>
-              <a:t>[HOST_2_IF_AGENT_AGENT]</a:t>
-            </a:r>
-            <a:endParaRPr lang="en-US" sz="1100" dirty="0"/>
-          </a:p>
-        </p:txBody>
-      </p:sp>
-      <p:sp>
-        <p:nvSpPr>
-          <p:cNvPr id="28" name="Text 22"/>
-          <p:cNvSpPr txBox="1"/>
-          <p:nvPr/>
-        </p:nvSpPr>
-        <p:spPr>
-          <a:xfrm>
-            <a:off x="6583680" y="4864608"/>
-            <a:ext cx="4937760" cy="201168"/>
-          </a:xfrm>
-          <a:prstGeom prst="rect">
-            <a:avLst/>
-          </a:prstGeom>
-          <a:noFill/>
-          <a:ln/>
-        </p:spPr>
-        <p:txBody>
-          <a:bodyPr wrap="square" lIns="0" tIns="0" rIns="0" bIns="0" rtlCol="0" anchor="ctr"/>
-          <a:lstStyle/>
-          <a:p>
-            <a:pPr indent="0" marL="0">
-              <a:buNone/>
-            </a:pPr>
-            <a:r>
-              <a:rPr lang="en-US" sz="1000" b="1" dirty="0">
-                <a:solidFill>
-                  <a:srgbClr val="00D4D8"/>
-                </a:solidFill>
-                <a:latin typeface="Courier New" pitchFamily="34" charset="0"/>
-                <a:ea typeface="Courier New" pitchFamily="34" charset="-122"/>
-                <a:cs typeface="Courier New" pitchFamily="34" charset="-120"/>
-              </a:rPr>
-              <a:t>BIO:</a:t>
-            </a:r>
-            <a:endParaRPr lang="en-US" sz="1000" dirty="0"/>
-          </a:p>
-        </p:txBody>
-      </p:sp>
-      <p:sp>
-        <p:nvSpPr>
-          <p:cNvPr id="29" name="Text 23"/>
-          <p:cNvSpPr txBox="1"/>
-          <p:nvPr/>
-        </p:nvSpPr>
-        <p:spPr>
-          <a:xfrm>
-            <a:off x="6583680" y="5084064"/>
-            <a:ext cx="4937760" cy="1005840"/>
-          </a:xfrm>
-          <a:prstGeom prst="rect">
-            <a:avLst/>
-          </a:prstGeom>
-          <a:noFill/>
-          <a:ln/>
-        </p:spPr>
-        <p:txBody>
-          <a:bodyPr wrap="square" lIns="0" tIns="0" rIns="0" bIns="0" rtlCol="0" anchor="t"/>
-          <a:lstStyle/>
-          <a:p>
-            <a:pPr indent="0" marL="0">
-              <a:buNone/>
-            </a:pPr>
-            <a:r>
-              <a:rPr lang="en-US" sz="1100" dirty="0">
-                <a:solidFill>
-                  <a:srgbClr val="CCCCCC"/>
-                </a:solidFill>
-                <a:latin typeface="Calibri" pitchFamily="34" charset="0"/>
-                <a:ea typeface="Calibri" pitchFamily="34" charset="-122"/>
-                <a:cs typeface="Calibri" pitchFamily="34" charset="-120"/>
-              </a:rPr>
               <a:t>[HOST_2_BIO_AGENT]</a:t>
-            </a:r>
-            <a:endParaRPr lang="en-US" sz="1100" dirty="0"/>
-          </a:p>
-        </p:txBody>
-      </p:sp>
-      <p:sp>
-        <p:nvSpPr>
-          <p:cNvPr id="30" name="Text 24"/>
-          <p:cNvSpPr txBox="1"/>
-          <p:nvPr/>
-        </p:nvSpPr>
-        <p:spPr>
-          <a:xfrm>
-            <a:off x="694944" y="6291072"/>
-            <a:ext cx="10789920" cy="411480"/>
-          </a:xfrm>
-          <a:prstGeom prst="rect">
-            <a:avLst/>
-          </a:prstGeom>
-          <a:noFill/>
-          <a:ln/>
-        </p:spPr>
-        <p:txBody>
-          <a:bodyPr wrap="square" lIns="0" tIns="0" rIns="0" bIns="0" rtlCol="0" anchor="t"/>
-          <a:lstStyle/>
-          <a:p>
-            <a:pPr algn="ctr" indent="0" marL="0">
-              <a:buNone/>
-            </a:pPr>
-            <a:r>
-              <a:rPr lang="en-US" sz="1100" i="1" dirty="0">
-                <a:solidFill>
-                  <a:srgbClr val="A9A29A"/>
-                </a:solidFill>
-                <a:latin typeface="Calibri" pitchFamily="34" charset="0"/>
-                <a:ea typeface="Calibri" pitchFamily="34" charset="-122"/>
-                <a:cs typeface="Calibri" pitchFamily="34" charset="-120"/>
-              </a:rPr>
-              <a:t>LinkedIn roast: [HOST_2_ROAST]</a:t>
             </a:r>
             <a:endParaRPr lang="en-US" sz="1100" dirty="0"/>
           </a:p>

</xml_diff>